<commit_message>
Actualización general de Documentación
</commit_message>
<xml_diff>
--- a/Fase 2/Evidencias Proyecto/Presentación Proyecto/CuTuCo Fase2.pptx
+++ b/Fase 2/Evidencias Proyecto/Presentación Proyecto/CuTuCo Fase2.pptx
@@ -260,23 +260,28 @@
           <c:dLbls>
             <c:dLbl>
               <c:idx val="0"/>
+              <c:tx>
+                <c:rich>
+                  <a:bodyPr/>
+                  <a:lstStyle/>
+                  <a:p>
+                    <a:pPr>
+                      <a:defRPr sz="1800" b="1" i="0" u="none" strike="noStrike">
+                        <a:solidFill>
+                          <a:srgbClr val="FFFFFF"/>
+                        </a:solidFill>
+                        <a:latin typeface="+mn-lt"/>
+                      </a:defRPr>
+                    </a:pPr>
+                    <a:r>
+                      <a:rPr lang="en-US" dirty="0"/>
+                      <a:t>7</a:t>
+                    </a:r>
+                  </a:p>
+                </c:rich>
+              </c:tx>
               <c:numFmt formatCode="General" sourceLinked="0"/>
               <c:spPr/>
-              <c:txPr>
-                <a:bodyPr/>
-                <a:lstStyle/>
-                <a:p>
-                  <a:pPr>
-                    <a:defRPr sz="1800" b="1" i="0" u="none" strike="noStrike">
-                      <a:solidFill>
-                        <a:srgbClr val="FFFFFF"/>
-                      </a:solidFill>
-                      <a:latin typeface="+mn-lt"/>
-                    </a:defRPr>
-                  </a:pPr>
-                  <a:endParaRPr lang="es-CL"/>
-                </a:p>
-              </c:txPr>
               <c:showLegendKey val="0"/>
               <c:showVal val="1"/>
               <c:showCatName val="0"/>
@@ -284,7 +289,9 @@
               <c:showPercent val="0"/>
               <c:showBubbleSize val="0"/>
               <c:extLst>
-                <c:ext xmlns:c15="http://schemas.microsoft.com/office/drawing/2012/chart" uri="{CE6537A1-D6FC-4f65-9D91-7224C49458BB}"/>
+                <c:ext xmlns:c15="http://schemas.microsoft.com/office/drawing/2012/chart" uri="{CE6537A1-D6FC-4f65-9D91-7224C49458BB}">
+                  <c15:showDataLabelsRange val="0"/>
+                </c:ext>
                 <c:ext xmlns:c16="http://schemas.microsoft.com/office/drawing/2014/chart" uri="{C3380CC4-5D6E-409C-BE32-E72D297353CC}">
                   <c16:uniqueId val="{00000001-3299-4A19-998E-AEE9EEF3C19F}"/>
                 </c:ext>
@@ -292,23 +299,28 @@
             </c:dLbl>
             <c:dLbl>
               <c:idx val="1"/>
+              <c:tx>
+                <c:rich>
+                  <a:bodyPr/>
+                  <a:lstStyle/>
+                  <a:p>
+                    <a:pPr>
+                      <a:defRPr sz="1800" b="1" i="0" u="none" strike="noStrike">
+                        <a:solidFill>
+                          <a:srgbClr val="FFFFFF"/>
+                        </a:solidFill>
+                        <a:latin typeface="+mn-lt"/>
+                      </a:defRPr>
+                    </a:pPr>
+                    <a:r>
+                      <a:rPr lang="en-US" dirty="0"/>
+                      <a:t>3</a:t>
+                    </a:r>
+                  </a:p>
+                </c:rich>
+              </c:tx>
               <c:numFmt formatCode="General" sourceLinked="0"/>
               <c:spPr/>
-              <c:txPr>
-                <a:bodyPr/>
-                <a:lstStyle/>
-                <a:p>
-                  <a:pPr>
-                    <a:defRPr sz="1800" b="1" i="0" u="none" strike="noStrike">
-                      <a:solidFill>
-                        <a:srgbClr val="FFFFFF"/>
-                      </a:solidFill>
-                      <a:latin typeface="+mn-lt"/>
-                    </a:defRPr>
-                  </a:pPr>
-                  <a:endParaRPr lang="es-CL"/>
-                </a:p>
-              </c:txPr>
               <c:showLegendKey val="0"/>
               <c:showVal val="1"/>
               <c:showCatName val="0"/>
@@ -316,7 +328,9 @@
               <c:showPercent val="0"/>
               <c:showBubbleSize val="0"/>
               <c:extLst>
-                <c:ext xmlns:c15="http://schemas.microsoft.com/office/drawing/2012/chart" uri="{CE6537A1-D6FC-4f65-9D91-7224C49458BB}"/>
+                <c:ext xmlns:c15="http://schemas.microsoft.com/office/drawing/2012/chart" uri="{CE6537A1-D6FC-4f65-9D91-7224C49458BB}">
+                  <c15:showDataLabelsRange val="0"/>
+                </c:ext>
                 <c:ext xmlns:c16="http://schemas.microsoft.com/office/drawing/2014/chart" uri="{C3380CC4-5D6E-409C-BE32-E72D297353CC}">
                   <c16:uniqueId val="{00000003-3299-4A19-998E-AEE9EEF3C19F}"/>
                 </c:ext>
@@ -324,23 +338,28 @@
             </c:dLbl>
             <c:dLbl>
               <c:idx val="2"/>
+              <c:tx>
+                <c:rich>
+                  <a:bodyPr/>
+                  <a:lstStyle/>
+                  <a:p>
+                    <a:pPr>
+                      <a:defRPr sz="1800" b="1" i="0" u="none" strike="noStrike">
+                        <a:solidFill>
+                          <a:srgbClr val="FFFFFF"/>
+                        </a:solidFill>
+                        <a:latin typeface="+mn-lt"/>
+                      </a:defRPr>
+                    </a:pPr>
+                    <a:r>
+                      <a:rPr lang="en-US" dirty="0"/>
+                      <a:t>3</a:t>
+                    </a:r>
+                  </a:p>
+                </c:rich>
+              </c:tx>
               <c:numFmt formatCode="General" sourceLinked="0"/>
               <c:spPr/>
-              <c:txPr>
-                <a:bodyPr/>
-                <a:lstStyle/>
-                <a:p>
-                  <a:pPr>
-                    <a:defRPr sz="1800" b="1" i="0" u="none" strike="noStrike">
-                      <a:solidFill>
-                        <a:srgbClr val="FFFFFF"/>
-                      </a:solidFill>
-                      <a:latin typeface="+mn-lt"/>
-                    </a:defRPr>
-                  </a:pPr>
-                  <a:endParaRPr lang="es-CL"/>
-                </a:p>
-              </c:txPr>
               <c:showLegendKey val="0"/>
               <c:showVal val="1"/>
               <c:showCatName val="0"/>
@@ -348,7 +367,9 @@
               <c:showPercent val="0"/>
               <c:showBubbleSize val="0"/>
               <c:extLst>
-                <c:ext xmlns:c15="http://schemas.microsoft.com/office/drawing/2012/chart" uri="{CE6537A1-D6FC-4f65-9D91-7224C49458BB}"/>
+                <c:ext xmlns:c15="http://schemas.microsoft.com/office/drawing/2012/chart" uri="{CE6537A1-D6FC-4f65-9D91-7224C49458BB}">
+                  <c15:showDataLabelsRange val="0"/>
+                </c:ext>
                 <c:ext xmlns:c16="http://schemas.microsoft.com/office/drawing/2014/chart" uri="{C3380CC4-5D6E-409C-BE32-E72D297353CC}">
                   <c16:uniqueId val="{00000005-3299-4A19-998E-AEE9EEF3C19F}"/>
                 </c:ext>
@@ -412,13 +433,13 @@
                 <c:formatCode>General</c:formatCode>
                 <c:ptCount val="3"/>
                 <c:pt idx="0">
-                  <c:v>5</c:v>
+                  <c:v>7</c:v>
                 </c:pt>
                 <c:pt idx="1">
-                  <c:v>4</c:v>
+                  <c:v>3</c:v>
                 </c:pt>
                 <c:pt idx="2">
-                  <c:v>4</c:v>
+                  <c:v>3</c:v>
                 </c:pt>
               </c:numCache>
             </c:numRef>
@@ -439,7 +460,7 @@
           <c:showLeaderLines val="0"/>
         </c:dLbls>
         <c:firstSliceAng val="0"/>
-        <c:holeSize val="58"/>
+        <c:holeSize val="43"/>
       </c:doughnutChart>
       <c:spPr>
         <a:noFill/>
@@ -866,7 +887,7 @@
           <a:p>
             <a:fld id="{DDA92F09-5C33-4A61-9DDE-17FA27B31F65}" type="datetimeFigureOut">
               <a:rPr lang="es-CL" smtClean="0"/>
-              <a:t>07-10-2026</a:t>
+              <a:t>15-10-2026</a:t>
             </a:fld>
             <a:endParaRPr lang="es-CL"/>
           </a:p>
@@ -1132,7 +1153,7 @@
           <a:p>
             <a:r>
               <a:rPr lang="en-US" dirty="0"/>
-              <a:t>Presentación del avance de la Fase 2 del Proyecto APT. CuTuCo evoluciona desde un prototipo móvil hacia un marketplace web desacoplado. Estado al 4 de octubre de 2026 (semana 4 de 13).</a:t>
+              <a:t>Presentación del avance de la Fase 2 del Proyecto APT. CuTuCo evoluciona desde un prototipo móvil hacia un marketplace web desacoplado. Estado al 15 de octubre de 2026 (semana 5 de 13).</a:t>
             </a:r>
           </a:p>
         </p:txBody>
@@ -1219,7 +1240,7 @@
           <a:p>
             <a:r>
               <a:rPr lang="en-US" dirty="0"/>
-              <a:t>El alcance final queda en 21 de los 26 requerimientos originales. Se descartaron cinco y se simplificaron otros para que el proyecto sea viable para un equipo de dos personas en 13 semanas. Cualquier función descartada solo vuelve con una decisión formal de cambio.</a:t>
+              <a:t>El alcance vigente queda en 22 requerimientos: los 21 anteriores más RF-027 (Gestión de Reclamos). Se descartaron cinco requerimientos (RF-008, RF-010, RF-013, RF-015 y RF-016) y se retiraron de los flujos activos el escrow o custodia de fondos, las retenciones, los payouts y los reembolsos, que quedan registrados como historial de alcance. Cualquier función descartada solo vuelve con una decisión formal de cambio.</a:t>
             </a:r>
           </a:p>
         </p:txBody>
@@ -1305,7 +1326,7 @@
           <a:lstStyle/>
           <a:p>
             <a:r>
-              <a:t>Este es el recorrido que valida el producto, en orden: invitado, compra con validación de región, pago con Webpay Plus Test, retención de la venta, entrega con código, calificación de 1 a 5 y, al final, la liquidación. La gestión del pago (payout manual y reembolsos) es un proceso interno de CuTuCo: ocurre en las últimas etapas del flujo, después de la calificación. El fee base es de 5% más una tarifa fija de delivery de 3.500 CLP.</a:t>
+              <a:t>Este es el recorrido que valida el producto, en orden: invitado, compra con validación de región, pago con Webpay Mall (Split Payment), dispersión directa al productor, entrega con código, calificación de 1 a 5 y, al final, la resolución de reclamos, sanciones y apelaciones. CuTuCo no retiene fondos ni ejecuta payouts: la pasarela dispersa el pago al confirmarse la transacción. El fee base es de 5% más una tarifa fija de delivery de 3.500 CLP, y ambos se descuentan en el Split Payment.</a:t>
             </a:r>
           </a:p>
         </p:txBody>
@@ -1392,7 +1413,7 @@
           <a:p>
             <a:r>
               <a:rPr lang="en-US" dirty="0"/>
-              <a:t>Los quince riesgos están clasificados por probabilidad e impacto: seis críticos, cinco altos y cuatro medios. Los más urgentes son control de alcance y cierre con errores críticos. Todos tienen respuesta de mitigación y se revisan semanalmente.</a:t>
+              <a:t>Los dieciocho riesgos están clasificados por probabilidad e impacto: seis críticos, ocho altos y cuatro medios. Los más urgentes son control de alcance y cierre con errores críticos. Todos tienen respuesta de mitigación y se revisan semanalmente. La matriz incorpora tres riesgos nuevos sobre las obligaciones legales del vendedor: patente comercial, resolución sanitaria y comprobantes de la venta.</a:t>
             </a:r>
           </a:p>
         </p:txBody>
@@ -1478,7 +1499,7 @@
           <a:lstStyle/>
           <a:p>
             <a:r>
-              <a:t>La estrategia prueba primero unidades pequeñas, luego las conexiones y al final los flujos completos. Para las pruebas API y de base de datos usamos solo Pytest: no incluimos Postman porque implica un mayor consumo de HH. La pasarela se prueba con el Transbank SDK Test en Modo Integración, el modo que se nos proporciona para realizar las pruebas con datos mock, lo que permite emular las transferencias. Se priorizan los flujos que afectan dinero, seguridad y confianza y las metas de calidad se revisan cada semana desde la semana 6.</a:t>
+              <a:t>La estrategia prueba primero unidades pequeñas, luego las conexiones y al final los flujos completos. Para las pruebas unitarias y de integración del backend usamos Pytest con httpx, sin herramientas de cliente HTTP externas; Vitest cubre la integración del frontend. La pasarela se prueba con el Transbank SDK en Modo Integración, el modo que se nos proporciona para realizar las pruebas con datos mock, lo que permite emular las transferencias. Se priorizan los flujos que afectan dinero, seguridad y confianza y las metas de calidad se revisan cada semana desde la semana 6.</a:t>
             </a:r>
           </a:p>
         </p:txBody>
@@ -1564,7 +1585,7 @@
           <a:lstStyle/>
           <a:p>
             <a:r>
-              <a:t>Validación contra el EDT y el flujo de caja del plan de costos: el presupuesto base es la Opción A, con niveles gratuitos y créditos de GCP. El total estimado es de $5.626.158 y el desembolso real con contingencia es de $338.870, compuesto por $308.064 de infraestructura y otros costos más 10 % de contingencia. Las 520 horas del escenario base salen del desglose de HH del EDT: 260 horas por integrante a 20 horas semanales durante 13 semanas, repartidas por rol (JP 50, ASW 45, DBA 45 y PFS 1 120 en Vicente; AP 60 y PFS 2 200 en Ignacio), valorizadas en $4.806.625 a precio de mercado. El trabajo del equipo está valorizado, pero no se paga. Al corte de la semana 4 el gasto real es de $81.143 sobre $308.064 planificados, con 136 horas ejecutadas y 0 % de desviación. La Opción B es una proyección de producción y no está incluida.</a:t>
+              <a:t>Validación contra el EDT y el flujo de caja del plan de costos: el presupuesto base es la Opción A, con niveles gratuitos y créditos de GCP. El total estimado es de $5.626.158 y el desembolso real con contingencia es de $338.870, compuesto por $308.064 de infraestructura y otros costos más 10 % de contingencia. Las 520 horas del escenario base salen del desglose de HH del EDT: 260 horas por integrante a 20 horas semanales durante 13 semanas, repartidas por rol (JP 50, ASW 45, DBA 45 y PFS 1 120 en Vicente; AP 60 y PFS 2 200 en Ignacio), valorizadas en $4.806.625 a precio de mercado. El trabajo del equipo está valorizado, pero no se paga. Al corte del 05/10 (semana 4) el gasto real es de $81.143 sobre $308.064 planificados, con 136 horas ejecutadas y 0 % de desviación. La Opción B es una proyección de producción y no está incluida, y los trámites de constitución, patente municipal y resolución sanitaria quedan en $0 hasta contar con cotización.</a:t>
             </a:r>
           </a:p>
         </p:txBody>
@@ -1650,7 +1671,7 @@
           <a:lstStyle/>
           <a:p>
             <a:r>
-              <a:t>Estas son las evidencias que respaldan el avance. Los documentos de planificación y buena parte del diseño están entregados. El recorte de alcance obligó a recorregir y actualizar los documentos base (ERS, EDT, modelo de datos y plan de pruebas inicial), y esa recorrección se incorpora de forma explícita como evidencia de avance. Modelo de datos, mockups y la base técnica están en curso. Los resultados de pruebas y las capturas de interfaz se agregarán a medida que se completen los flujos.</a:t>
+              <a:t>Estas son las evidencias que respaldan el avance. Los documentos de planificación y de análisis y diseño están entregados y actualizados al alcance vigente. El ajuste de alcance obligó a corregir los documentos base (ERS, EDT, modelo de datos, plan de pruebas y plan de calidad y costos), y esa corrección se incorpora de forma explícita como evidencia de avance. Los scripts de base de datos, la configuración de despliegue y las minutas de control siguen en curso. Los resultados de pruebas y las capturas de interfaz se agregarán a medida que se completen los flujos.</a:t>
             </a:r>
           </a:p>
         </p:txBody>
@@ -1736,7 +1757,7 @@
           <a:lstStyle/>
           <a:p>
             <a:r>
-              <a:t>El principal facilitador es contar con un MVP funcional y una planificación ya documentada. La principal dificultad es que la evolución técnica es mucho mayor que la de un CRUD básico: RLS (Row Level Security), policies y grants por rol, funciones RPC para la lógica de negocio, la migración de SQLite a PostgreSQL, los pagos en custodia, la integración con Transbank y las transacciones con restricciones UNIQUE e idempotencia. Todo eso se resuelve por capas, con transacciones y validaciones, y somos solo dos personas con dependencias externas.</a:t>
+              <a:t>El principal facilitador es contar con un MVP funcional y una planificación ya documentada. La principal dificultad es que la evolución técnica es mucho mayor que la de un CRUD básico: RLS (Row Level Security), policies y grants por rol, triggers y funciones en la base de datos, la migración de SQLite a PostgreSQL, la integración con Transbank y las transacciones con restricciones UNIQUE e idempotencia. Todo eso se resuelve por capas, con transacciones y validaciones, y somos solo dos personas con dependencias externas.</a:t>
             </a:r>
           </a:p>
         </p:txBody>
@@ -1823,7 +1844,7 @@
           <a:p>
             <a:r>
               <a:rPr lang="en-US" dirty="0"/>
-              <a:t>Los ajustes mantienen el proyecto viable para dos personas en 13 semanas. No se eliminó ninguna funcionalidad oficial validada: se simplificó la forma de implementarla. Cualquier función descartada solo vuelve con una decisión formal.</a:t>
+              <a:t>Los ajustes mantienen el proyecto viable para dos personas en 13 semanas. El alcance vigente queda en 22 requerimientos: se simplificó la forma de implementar varias funciones y se retiraron de los flujos activos la custodia de fondos, los payouts y los reembolsos, que quedan registrados como historial de alcance. Cualquier función descartada solo vuelve con una decisión formal.</a:t>
             </a:r>
           </a:p>
         </p:txBody>
@@ -2170,7 +2191,7 @@
           <a:lstStyle/>
           <a:p>
             <a:r>
-              <a:t>Se eligió un enfoque tradicional porque la pauta académica exige entregables formales, trazabilidad y control de alcance, y porque el equipo es de dos personas. Las fases se solapan parcialmente: al 4 de octubre estamos cerrando la fase 2 (análisis y diseño) y avanzando hacia la fase 3 (construcción), que ya tiene su base técnica en curso.</a:t>
+              <a:t>Se eligió un enfoque tradicional porque la pauta académica exige entregables formales, trazabilidad y control de alcance, y porque el equipo es de dos personas. Las fases se solapan parcialmente: al 15 de octubre la fase 2 (análisis y diseño) quedó cerrada y estamos en la fase 3 (construcción), que ya tiene su base técnica en curso.</a:t>
             </a:r>
           </a:p>
         </p:txBody>
@@ -2257,7 +2278,7 @@
           <a:p>
             <a:r>
               <a:rPr lang="en-US" dirty="0"/>
-              <a:t>Siete hitos de control. H01 está cerrado. H02 (análisis y diseño base) está en cierre: ERS, arquitectura y plan de calidad listos; modelo de datos y mockups en curso. El desarrollo termina en la semana 11 y las semanas 12 y 13 se reservan para documentación y entrega.</a:t>
+              <a:t>Siete hitos de control. H01 está cerrado. H02 (análisis y diseño base) está en su cierre final, con el ERS, la arquitectura, el modelo de datos, los mockups y el plan de calidad ya entregados y actualizados al alcance vigente. El desarrollo termina en la semana 11 y las semanas 12 y 13 se reservan para documentación y entrega.</a:t>
             </a:r>
           </a:p>
         </p:txBody>
@@ -2344,7 +2365,7 @@
           <a:p>
             <a:r>
               <a:rPr lang="en-US" dirty="0"/>
-              <a:t>Planificación, ERS, arquitectura y plan de pruebas están completados. Modelo de datos, UX/UI, backend y Supabase están en curso. Frontend, pagos, integración y documentación están programados para semanas posteriores y por eso se informan como pendientes, no como atrasados.</a:t>
+              <a:t>Planificación, ERS, arquitectura, modelo de datos, mockups y plan de pruebas están completados. Backend y Supabase están en curso. Frontend, pagos, integración y documentación están programados para semanas posteriores y por eso se informan como pendientes, no como atrasados. Las cifras de avance corresponden al último corte registrado, del 05/10 (semana 4).</a:t>
             </a:r>
           </a:p>
         </p:txBody>
@@ -2517,7 +2538,7 @@
           <a:lstStyle/>
           <a:p>
             <a:r>
-              <a:t>La arquitectura separa presentación, API, persistencia y servicios externos. Las consultas simples y la autenticación van directo a Supabase; en FastAPI + Docker (Cloud Run) vive la lógica de negocio compleja: la integración con la pasarela de Transbank (Webpay Plus Test), el envío de correos con plantillas personalizadas, el cifrado parcial de datos sensibles, los pagos en custodia y el bloqueo tras 5 intentos fallidos. Para el MVP académico usamos la Opción A; la Opción B queda como proyección productiva.</a:t>
+              <a:t>La arquitectura separa presentación, API, persistencia y servicios externos. Las consultas simples, el CRUD y la autenticación van directo a Supabase, con roles, RLS, policies y grants; en FastAPI + Docker (Cloud Run) vive solo la lógica específica de la integración con Webpay Mall (Split Payment), donde la pasarela captura y dispersa el pago en tiempo real. Los correos salen con Resend y la habilitación de la cuenta de Transbank es un trámite externo a la plataforma. Para el MVP académico usamos la Opción A; la Opción B queda como proyección productiva.</a:t>
             </a:r>
           </a:p>
         </p:txBody>
@@ -2603,7 +2624,7 @@
           <a:lstStyle/>
           <a:p>
             <a:r>
-              <a:t>El modelo de datos ya fue rediseñado y corresponde a un modelo revisado y actualizado sobre el alcance final, no a una propuesta pendiente. Incorpora la tabla payouts para liquidar a los vendedores, y las reglas de integridad protegen pagos, stock y datos sensibles (buy_order y token_ws únicos, soft delete, RLS y policies por rol, stock con SELECT FOR UPDATE y cifrado de datos bancarios). Lo que queda en curso es la ejecución de la migración desde SQLite y la decisión de si se hace con ALTER TABLE o con recreación de tablas.</a:t>
+              <a:t>El modelo de datos ya fue rediseñado y corresponde a un modelo revisado y actualizado sobre el alcance final, no a una propuesta pendiente. La tabla payouts se retiró porque la dispersión la realiza la pasarela de Transbank; en su lugar el modelo incorpora los reclamos (RF-027) junto con payments y delivery_tracking. Las reglas de integridad protegen pagos y stock (buy_order y token_ws únicos, eliminación lógica, RLS y policies por rol y stock con SELECT FOR UPDATE). Los datos que envían los postulantes se protegen con roles, RLS, policies, grants y permisos de Storage, sin cifrado propio. Queda en curso la ejecución de la migración desde SQLite y la decisión de si se hace con ALTER TABLE o con recreación de tablas.</a:t>
             </a:r>
           </a:p>
         </p:txBody>
@@ -4611,7 +4632,7 @@
                 <a:ea typeface="Carlito Bold" pitchFamily="34" charset="-122"/>
                 <a:cs typeface="Carlito Bold" pitchFamily="34" charset="-120"/>
               </a:rPr>
-              <a:t>Alcance: 21 requerimientos</a:t>
+              <a:t>Alcance: 22 requerimientos</a:t>
             </a:r>
             <a:endParaRPr lang="en-US" sz="3400" dirty="0"/>
           </a:p>
@@ -5215,7 +5236,7 @@
                 <a:ea typeface="Carlito Bold" pitchFamily="34" charset="-122"/>
                 <a:cs typeface="Carlito Bold" pitchFamily="34" charset="-120"/>
               </a:rPr>
-              <a:t>Pago en custodia</a:t>
+              <a:t>Pago y dispersión</a:t>
             </a:r>
             <a:endParaRPr lang="en-US" sz="1600" dirty="0"/>
           </a:p>
@@ -5259,7 +5280,7 @@
                 <a:ea typeface="Carlito" pitchFamily="34" charset="-122"/>
                 <a:cs typeface="Carlito" pitchFamily="34" charset="-120"/>
               </a:rPr>
-              <a:t>Webpay Plus Test, retención de la venta, payout manual y tarifas</a:t>
+              <a:t>Webpay Mall: la pasarela dispersa el pago y descuenta el fee</a:t>
             </a:r>
             <a:endParaRPr lang="en-US" sz="1300" dirty="0"/>
           </a:p>
@@ -5335,7 +5356,7 @@
                 <a:ea typeface="Carlito Bold" pitchFamily="34" charset="-122"/>
                 <a:cs typeface="Carlito Bold" pitchFamily="34" charset="-120"/>
               </a:rPr>
-              <a:t>4</a:t>
+              <a:t>5</a:t>
             </a:r>
             <a:endParaRPr lang="en-US" sz="4000" dirty="0"/>
           </a:p>
@@ -5421,7 +5442,7 @@
                 <a:ea typeface="Carlito" pitchFamily="34" charset="-122"/>
                 <a:cs typeface="Carlito" pitchFamily="34" charset="-120"/>
               </a:rPr>
-              <a:t>Estados con código, calificación 1 a 5 y sanciones manuales</a:t>
+              <a:t>Estados con código, calificación 1 a 5, reclamos y sanciones</a:t>
             </a:r>
             <a:endParaRPr lang="en-US" sz="1300" dirty="0"/>
           </a:p>
@@ -5583,7 +5604,7 @@
                 <a:ea typeface="Carlito" pitchFamily="34" charset="-122"/>
                 <a:cs typeface="Carlito" pitchFamily="34" charset="-120"/>
               </a:rPr>
-              <a:t>Usuarios, moderación, dashboard, correos y validaciones</a:t>
+              <a:t>Usuarios, productos, dashboard, correos y validaciones</a:t>
             </a:r>
             <a:endParaRPr lang="en-US" sz="1300" dirty="0"/>
           </a:p>
@@ -5876,7 +5897,7 @@
                 <a:ea typeface="Carlito" pitchFamily="34" charset="-122"/>
                 <a:cs typeface="Carlito" pitchFamily="34" charset="-120"/>
               </a:rPr>
-              <a:t>También simplificados: GPS, fotos obligatorias y reputación algorítmica</a:t>
+              <a:t>También fuera: GPS, fotos obligatorias y reputación algorítmica</a:t>
             </a:r>
             <a:endParaRPr lang="en-US" sz="1200" dirty="0"/>
           </a:p>
@@ -6478,7 +6499,7 @@
                 <a:ea typeface="Carlito" pitchFamily="34" charset="-122"/>
                 <a:cs typeface="Carlito" pitchFamily="34" charset="-120"/>
               </a:rPr>
-              <a:t>Webpay Plus Test, sin duplicados</a:t>
+              <a:t>Webpay Mall, sin duplicados</a:t>
             </a:r>
             <a:endParaRPr lang="en-US" sz="1300" dirty="0"/>
           </a:p>
@@ -6576,7 +6597,7 @@
                 <a:ea typeface="Carlito Bold" pitchFamily="34" charset="-122"/>
                 <a:cs typeface="Carlito Bold" pitchFamily="34" charset="-120"/>
               </a:rPr>
-              <a:t>4. Retener</a:t>
+              <a:t>4. Dispersar</a:t>
             </a:r>
             <a:endParaRPr lang="en-US" sz="1600" dirty="0"/>
           </a:p>
@@ -6620,7 +6641,7 @@
                 <a:ea typeface="Carlito" pitchFamily="34" charset="-122"/>
                 <a:cs typeface="Carlito" pitchFamily="34" charset="-120"/>
               </a:rPr>
-              <a:t>CuTuCo retiene la venta</a:t>
+              <a:t>La pasarela deposita al productor</a:t>
             </a:r>
             <a:endParaRPr lang="en-US" sz="1300" dirty="0"/>
           </a:p>
@@ -6908,7 +6929,7 @@
                 </a:solidFill>
                 <a:latin typeface="Carlito"/>
               </a:rPr>
-              <a:t>Nota de 1 a 5; alimenta la liquidación</a:t>
+              <a:t>Nota de 1 a 5 y promedio del vendedor</a:t>
             </a:r>
             <a:endParaRPr lang="en-US" sz="1300" dirty="0"/>
           </a:p>
@@ -7009,7 +7030,7 @@
                 </a:solidFill>
                 <a:latin typeface="Carlito Bold"/>
               </a:rPr>
-              <a:t>7. Liquidar</a:t>
+              <a:t>7. Resolver</a:t>
             </a:r>
             <a:endParaRPr lang="en-US" sz="1600" dirty="0"/>
           </a:p>
@@ -7054,7 +7075,7 @@
                 </a:solidFill>
                 <a:latin typeface="Carlito"/>
               </a:rPr>
-              <a:t>Interno: payout manual, venta menos 5% y $3.500</a:t>
+              <a:t>Reclamos, sanciones y apelaciones</a:t>
             </a:r>
             <a:endParaRPr lang="en-US" sz="1300" dirty="0"/>
           </a:p>
@@ -7189,7 +7210,7 @@
                 </a:solidFill>
                 <a:latin typeface="Carlito Bold"/>
               </a:rPr>
-              <a:t>Flujo verificado de punta a punta: la liquidación es un proceso interno posterior</a:t>
+              <a:t>Flujo verificado de punta a punta: la pasarela dispersa el pago al confirmar</a:t>
             </a:r>
             <a:endParaRPr lang="en-US" sz="1800" dirty="0"/>
           </a:p>
@@ -7234,7 +7255,7 @@
                 </a:solidFill>
                 <a:latin typeface="Carlito"/>
               </a:rPr>
-              <a:t>La calificación cierra el pedido y solo después CuTuCo ejecuta la gestión del pago (payout manual y reembolsos), que es interna y no un paso del usuario. Pruebas E2E con Cypress, semanas 9 a 11: si un servicio externo bloquea una prueba se usan mocks y la validación real queda pendiente.</a:t>
+              <a:t>Al confirmarse el pago, la pasarela captura y dispersa el monto al productor en tiempo real: CuTuCo no retiene fondos ni ejecuta payouts. Pruebas E2E con Cypress, semanas 9 a 11: si un servicio externo bloquea una prueba se usan mocks y la validación real queda pendiente.</a:t>
             </a:r>
             <a:endParaRPr lang="en-US" sz="1400" dirty="0"/>
           </a:p>
@@ -7579,7 +7600,7 @@
                 <a:ea typeface="Carlito Bold" pitchFamily="34" charset="-122"/>
                 <a:cs typeface="Carlito Bold" pitchFamily="34" charset="-120"/>
               </a:rPr>
-              <a:t>5</a:t>
+              <a:t>8</a:t>
             </a:r>
             <a:endParaRPr lang="en-US" sz="4400" dirty="0"/>
           </a:p>
@@ -8827,7 +8848,7 @@
                           <a:ea typeface="Carlito" pitchFamily="34" charset="-122"/>
                           <a:cs typeface="Carlito" pitchFamily="34" charset="-120"/>
                         </a:rPr>
-                        <a:t>Integración con Webpay Plus</a:t>
+                        <a:t>Integración con Webpay Mall</a:t>
                       </a:r>
                       <a:endParaRPr lang="en-US" sz="1300" dirty="0">
                         <a:latin typeface="Carlito" charset="0"/>
@@ -9159,7 +9180,7 @@
                           <a:ea typeface="Carlito" pitchFamily="34" charset="-122"/>
                           <a:cs typeface="Carlito" pitchFamily="34" charset="-120"/>
                         </a:rPr>
-                        <a:t>Prueba de cada policy por rol y bloqueo tras 5 intentos</a:t>
+                        <a:t>Prueba de cada policy por rol con GoTrue</a:t>
                       </a:r>
                       <a:endParaRPr lang="en-US" sz="1300" dirty="0">
                         <a:latin typeface="Carlito" charset="0"/>
@@ -9253,7 +9274,7 @@
                 <a:ea typeface="Carlito" pitchFamily="34" charset="-122"/>
                 <a:cs typeface="Carlito" pitchFamily="34" charset="-120"/>
               </a:rPr>
-              <a:t>Matriz de 15 riesgos (probabilidad × impacto). Se muestran los 6 de mayor nivel; todos con respuesta de mitigación.</a:t>
+              <a:t>Matriz de 18 riesgos (probabilidad × impacto). Se muestran los 6 de mayor nivel; todos con respuesta de mitigación.</a:t>
             </a:r>
             <a:endParaRPr lang="en-US" sz="1200" dirty="0"/>
           </a:p>
@@ -9480,7 +9501,7 @@
                 <a:ea typeface="Carlito Bold" pitchFamily="34" charset="-122"/>
                 <a:cs typeface="Carlito Bold" pitchFamily="34" charset="-120"/>
               </a:rPr>
-              <a:t>21/21</a:t>
+              <a:t>22/22</a:t>
             </a:r>
             <a:endParaRPr lang="en-US" sz="3600" dirty="0"/>
           </a:p>
@@ -10421,7 +10442,7 @@
                     <a:p>
                       <a:r>
                         <a:rPr sz="1150"/>
-                        <a:t>Pytest</a:t>
+                        <a:t>Pytest + httpx</a:t>
                       </a:r>
                     </a:p>
                   </a:txBody>
@@ -11371,7 +11392,7 @@
                 </a:solidFill>
                 <a:latin typeface="Carlito"/>
               </a:rPr>
-              <a:t>Solo Pytest para unitarias, API y BD. El Transbank SDK Test en Modo Integración es el modo que se nos proporciona para probar con datos mock y emular las transferencias.</a:t>
+              <a:t>Pytest y httpx para unitarias, API y BD; Vitest para el frontend. El Transbank SDK en Modo Integración permite probar con datos mock.</a:t>
             </a:r>
             <a:endParaRPr lang="en-US" sz="1200" dirty="0"/>
           </a:p>
@@ -11960,7 +11981,7 @@
                 </a:solidFill>
                 <a:latin typeface="Carlito"/>
               </a:rPr>
-              <a:t>Consistente con el flujo de caja del plan de costos: total estimado $5.626.158 y desembolso en efectivo con contingencia $338.870. Al corte (S4): $81.143 sobre $308.064 y 0 % de desviación. Opción B productiva: USD 100 a 120 al mes, fuera del presupuesto.</a:t>
+              <a:t>Consistente con el flujo de caja del plan de costos: total estimado $5.626.158 y desembolso en efectivo con contingencia $338.870. Al corte del 05/10 (S4): $81.143 sobre $308.064 y 0 % de desviación. Opción B productiva: USD 100 a 120 al mes, fuera del presupuesto.</a:t>
             </a:r>
             <a:endParaRPr lang="en-US" sz="1300" dirty="0"/>
           </a:p>
@@ -13803,457 +13824,7 @@
                 </a:solidFill>
                 <a:latin typeface="Carlito"/>
               </a:rPr>
-              <a:t>El </a:t>
-            </a:r>
-            <a:r>
-              <a:rPr sz="1100" dirty="0" err="1">
-                <a:solidFill>
-                  <a:srgbClr val="5B6577"/>
-                </a:solidFill>
-                <a:latin typeface="Carlito"/>
-              </a:rPr>
-              <a:t>recorte</a:t>
-            </a:r>
-            <a:r>
-              <a:rPr sz="1100" dirty="0">
-                <a:solidFill>
-                  <a:srgbClr val="5B6577"/>
-                </a:solidFill>
-                <a:latin typeface="Carlito"/>
-              </a:rPr>
-              <a:t> de </a:t>
-            </a:r>
-            <a:r>
-              <a:rPr sz="1100" dirty="0" err="1">
-                <a:solidFill>
-                  <a:srgbClr val="5B6577"/>
-                </a:solidFill>
-                <a:latin typeface="Carlito"/>
-              </a:rPr>
-              <a:t>alcance</a:t>
-            </a:r>
-            <a:r>
-              <a:rPr sz="1100" dirty="0">
-                <a:solidFill>
-                  <a:srgbClr val="5B6577"/>
-                </a:solidFill>
-                <a:latin typeface="Carlito"/>
-              </a:rPr>
-              <a:t> </a:t>
-            </a:r>
-            <a:r>
-              <a:rPr sz="1100" dirty="0" err="1">
-                <a:solidFill>
-                  <a:srgbClr val="5B6577"/>
-                </a:solidFill>
-                <a:latin typeface="Carlito"/>
-              </a:rPr>
-              <a:t>obligó</a:t>
-            </a:r>
-            <a:r>
-              <a:rPr sz="1100" dirty="0">
-                <a:solidFill>
-                  <a:srgbClr val="5B6577"/>
-                </a:solidFill>
-                <a:latin typeface="Carlito"/>
-              </a:rPr>
-              <a:t> a </a:t>
-            </a:r>
-            <a:r>
-              <a:rPr sz="1100" dirty="0" err="1">
-                <a:solidFill>
-                  <a:srgbClr val="5B6577"/>
-                </a:solidFill>
-                <a:latin typeface="Carlito"/>
-              </a:rPr>
-              <a:t>recorregir</a:t>
-            </a:r>
-            <a:r>
-              <a:rPr sz="1100" dirty="0">
-                <a:solidFill>
-                  <a:srgbClr val="5B6577"/>
-                </a:solidFill>
-                <a:latin typeface="Carlito"/>
-              </a:rPr>
-              <a:t> y </a:t>
-            </a:r>
-            <a:r>
-              <a:rPr sz="1100" dirty="0" err="1">
-                <a:solidFill>
-                  <a:srgbClr val="5B6577"/>
-                </a:solidFill>
-                <a:latin typeface="Carlito"/>
-              </a:rPr>
-              <a:t>actualizar</a:t>
-            </a:r>
-            <a:r>
-              <a:rPr sz="1100" dirty="0">
-                <a:solidFill>
-                  <a:srgbClr val="5B6577"/>
-                </a:solidFill>
-                <a:latin typeface="Carlito"/>
-              </a:rPr>
-              <a:t> </a:t>
-            </a:r>
-            <a:r>
-              <a:rPr sz="1100" dirty="0" err="1">
-                <a:solidFill>
-                  <a:srgbClr val="5B6577"/>
-                </a:solidFill>
-                <a:latin typeface="Carlito"/>
-              </a:rPr>
-              <a:t>los</a:t>
-            </a:r>
-            <a:r>
-              <a:rPr sz="1100" dirty="0">
-                <a:solidFill>
-                  <a:srgbClr val="5B6577"/>
-                </a:solidFill>
-                <a:latin typeface="Carlito"/>
-              </a:rPr>
-              <a:t> </a:t>
-            </a:r>
-            <a:r>
-              <a:rPr sz="1100" dirty="0" err="1">
-                <a:solidFill>
-                  <a:srgbClr val="5B6577"/>
-                </a:solidFill>
-                <a:latin typeface="Carlito"/>
-              </a:rPr>
-              <a:t>documentos</a:t>
-            </a:r>
-            <a:r>
-              <a:rPr sz="1100" dirty="0">
-                <a:solidFill>
-                  <a:srgbClr val="5B6577"/>
-                </a:solidFill>
-                <a:latin typeface="Carlito"/>
-              </a:rPr>
-              <a:t> base (ERS, EDT, </a:t>
-            </a:r>
-            <a:r>
-              <a:rPr sz="1100" dirty="0" err="1">
-                <a:solidFill>
-                  <a:srgbClr val="5B6577"/>
-                </a:solidFill>
-                <a:latin typeface="Carlito"/>
-              </a:rPr>
-              <a:t>modelo</a:t>
-            </a:r>
-            <a:r>
-              <a:rPr sz="1100" dirty="0">
-                <a:solidFill>
-                  <a:srgbClr val="5B6577"/>
-                </a:solidFill>
-                <a:latin typeface="Carlito"/>
-              </a:rPr>
-              <a:t> de </a:t>
-            </a:r>
-            <a:r>
-              <a:rPr sz="1100" dirty="0" err="1">
-                <a:solidFill>
-                  <a:srgbClr val="5B6577"/>
-                </a:solidFill>
-                <a:latin typeface="Carlito"/>
-              </a:rPr>
-              <a:t>datos</a:t>
-            </a:r>
-            <a:r>
-              <a:rPr sz="1100" dirty="0">
-                <a:solidFill>
-                  <a:srgbClr val="5B6577"/>
-                </a:solidFill>
-                <a:latin typeface="Carlito"/>
-              </a:rPr>
-              <a:t>, plan de </a:t>
-            </a:r>
-            <a:r>
-              <a:rPr sz="1100" dirty="0" err="1">
-                <a:solidFill>
-                  <a:srgbClr val="5B6577"/>
-                </a:solidFill>
-                <a:latin typeface="Carlito"/>
-              </a:rPr>
-              <a:t>pruebas</a:t>
-            </a:r>
-            <a:r>
-              <a:rPr sz="1100" dirty="0">
-                <a:solidFill>
-                  <a:srgbClr val="5B6577"/>
-                </a:solidFill>
-                <a:latin typeface="Carlito"/>
-              </a:rPr>
-              <a:t> y </a:t>
-            </a:r>
-            <a:r>
-              <a:rPr sz="1100" dirty="0" err="1">
-                <a:solidFill>
-                  <a:srgbClr val="5B6577"/>
-                </a:solidFill>
-                <a:latin typeface="Carlito"/>
-              </a:rPr>
-              <a:t>manuales</a:t>
-            </a:r>
-            <a:r>
-              <a:rPr sz="1100" dirty="0">
-                <a:solidFill>
-                  <a:srgbClr val="5B6577"/>
-                </a:solidFill>
-                <a:latin typeface="Carlito"/>
-              </a:rPr>
-              <a:t>); </a:t>
-            </a:r>
-            <a:r>
-              <a:rPr sz="1100" dirty="0" err="1">
-                <a:solidFill>
-                  <a:srgbClr val="5B6577"/>
-                </a:solidFill>
-                <a:latin typeface="Carlito"/>
-              </a:rPr>
-              <a:t>esa</a:t>
-            </a:r>
-            <a:r>
-              <a:rPr sz="1100" dirty="0">
-                <a:solidFill>
-                  <a:srgbClr val="5B6577"/>
-                </a:solidFill>
-                <a:latin typeface="Carlito"/>
-              </a:rPr>
-              <a:t> </a:t>
-            </a:r>
-            <a:r>
-              <a:rPr sz="1100" dirty="0" err="1">
-                <a:solidFill>
-                  <a:srgbClr val="5B6577"/>
-                </a:solidFill>
-                <a:latin typeface="Carlito"/>
-              </a:rPr>
-              <a:t>recorrección</a:t>
-            </a:r>
-            <a:r>
-              <a:rPr sz="1100" dirty="0">
-                <a:solidFill>
-                  <a:srgbClr val="5B6577"/>
-                </a:solidFill>
-                <a:latin typeface="Carlito"/>
-              </a:rPr>
-              <a:t> se </a:t>
-            </a:r>
-            <a:r>
-              <a:rPr sz="1100" dirty="0" err="1">
-                <a:solidFill>
-                  <a:srgbClr val="5B6577"/>
-                </a:solidFill>
-                <a:latin typeface="Carlito"/>
-              </a:rPr>
-              <a:t>presenta</a:t>
-            </a:r>
-            <a:r>
-              <a:rPr sz="1100" dirty="0">
-                <a:solidFill>
-                  <a:srgbClr val="5B6577"/>
-                </a:solidFill>
-                <a:latin typeface="Carlito"/>
-              </a:rPr>
-              <a:t> </a:t>
-            </a:r>
-            <a:r>
-              <a:rPr sz="1100" dirty="0" err="1">
-                <a:solidFill>
-                  <a:srgbClr val="5B6577"/>
-                </a:solidFill>
-                <a:latin typeface="Carlito"/>
-              </a:rPr>
-              <a:t>como</a:t>
-            </a:r>
-            <a:r>
-              <a:rPr sz="1100" dirty="0">
-                <a:solidFill>
-                  <a:srgbClr val="5B6577"/>
-                </a:solidFill>
-                <a:latin typeface="Carlito"/>
-              </a:rPr>
-              <a:t> </a:t>
-            </a:r>
-            <a:r>
-              <a:rPr sz="1100" dirty="0" err="1">
-                <a:solidFill>
-                  <a:srgbClr val="5B6577"/>
-                </a:solidFill>
-                <a:latin typeface="Carlito"/>
-              </a:rPr>
-              <a:t>evidencia</a:t>
-            </a:r>
-            <a:r>
-              <a:rPr sz="1100" dirty="0">
-                <a:solidFill>
-                  <a:srgbClr val="5B6577"/>
-                </a:solidFill>
-                <a:latin typeface="Carlito"/>
-              </a:rPr>
-              <a:t>. Las </a:t>
-            </a:r>
-            <a:r>
-              <a:rPr sz="1100" dirty="0" err="1">
-                <a:solidFill>
-                  <a:srgbClr val="5B6577"/>
-                </a:solidFill>
-                <a:latin typeface="Carlito"/>
-              </a:rPr>
-              <a:t>funciones</a:t>
-            </a:r>
-            <a:r>
-              <a:rPr sz="1100" dirty="0">
-                <a:solidFill>
-                  <a:srgbClr val="5B6577"/>
-                </a:solidFill>
-                <a:latin typeface="Carlito"/>
-              </a:rPr>
-              <a:t> de </a:t>
-            </a:r>
-            <a:r>
-              <a:rPr sz="1100" dirty="0" err="1">
-                <a:solidFill>
-                  <a:srgbClr val="5B6577"/>
-                </a:solidFill>
-                <a:latin typeface="Carlito"/>
-              </a:rPr>
-              <a:t>construcción</a:t>
-            </a:r>
-            <a:r>
-              <a:rPr sz="1100" dirty="0">
-                <a:solidFill>
-                  <a:srgbClr val="5B6577"/>
-                </a:solidFill>
-                <a:latin typeface="Carlito"/>
-              </a:rPr>
-              <a:t>, </a:t>
-            </a:r>
-            <a:r>
-              <a:rPr sz="1100" dirty="0" err="1">
-                <a:solidFill>
-                  <a:srgbClr val="5B6577"/>
-                </a:solidFill>
-                <a:latin typeface="Carlito"/>
-              </a:rPr>
-              <a:t>integración</a:t>
-            </a:r>
-            <a:r>
-              <a:rPr sz="1100" dirty="0">
-                <a:solidFill>
-                  <a:srgbClr val="5B6577"/>
-                </a:solidFill>
-                <a:latin typeface="Carlito"/>
-              </a:rPr>
-              <a:t> y </a:t>
-            </a:r>
-            <a:r>
-              <a:rPr sz="1100" dirty="0" err="1">
-                <a:solidFill>
-                  <a:srgbClr val="5B6577"/>
-                </a:solidFill>
-                <a:latin typeface="Carlito"/>
-              </a:rPr>
-              <a:t>pruebas</a:t>
-            </a:r>
-            <a:r>
-              <a:rPr sz="1100" dirty="0">
-                <a:solidFill>
-                  <a:srgbClr val="5B6577"/>
-                </a:solidFill>
-                <a:latin typeface="Carlito"/>
-              </a:rPr>
-              <a:t> finales </a:t>
-            </a:r>
-            <a:r>
-              <a:rPr sz="1100" dirty="0" err="1">
-                <a:solidFill>
-                  <a:srgbClr val="5B6577"/>
-                </a:solidFill>
-                <a:latin typeface="Carlito"/>
-              </a:rPr>
-              <a:t>siguen</a:t>
-            </a:r>
-            <a:r>
-              <a:rPr sz="1100" dirty="0">
-                <a:solidFill>
-                  <a:srgbClr val="5B6577"/>
-                </a:solidFill>
-                <a:latin typeface="Carlito"/>
-              </a:rPr>
-              <a:t> </a:t>
-            </a:r>
-            <a:r>
-              <a:rPr sz="1100" dirty="0" err="1">
-                <a:solidFill>
-                  <a:srgbClr val="5B6577"/>
-                </a:solidFill>
-                <a:latin typeface="Carlito"/>
-              </a:rPr>
-              <a:t>planificadas</a:t>
-            </a:r>
-            <a:r>
-              <a:rPr sz="1100" dirty="0">
-                <a:solidFill>
-                  <a:srgbClr val="5B6577"/>
-                </a:solidFill>
-                <a:latin typeface="Carlito"/>
-              </a:rPr>
-              <a:t>: no se </a:t>
-            </a:r>
-            <a:r>
-              <a:rPr sz="1100" dirty="0" err="1">
-                <a:solidFill>
-                  <a:srgbClr val="5B6577"/>
-                </a:solidFill>
-                <a:latin typeface="Carlito"/>
-              </a:rPr>
-              <a:t>presentan</a:t>
-            </a:r>
-            <a:r>
-              <a:rPr sz="1100" dirty="0">
-                <a:solidFill>
-                  <a:srgbClr val="5B6577"/>
-                </a:solidFill>
-                <a:latin typeface="Carlito"/>
-              </a:rPr>
-              <a:t> </a:t>
-            </a:r>
-            <a:r>
-              <a:rPr sz="1100" dirty="0" err="1">
-                <a:solidFill>
-                  <a:srgbClr val="5B6577"/>
-                </a:solidFill>
-                <a:latin typeface="Carlito"/>
-              </a:rPr>
-              <a:t>como</a:t>
-            </a:r>
-            <a:r>
-              <a:rPr sz="1100" dirty="0">
-                <a:solidFill>
-                  <a:srgbClr val="5B6577"/>
-                </a:solidFill>
-                <a:latin typeface="Carlito"/>
-              </a:rPr>
-              <a:t> </a:t>
-            </a:r>
-            <a:r>
-              <a:rPr sz="1100" dirty="0" err="1">
-                <a:solidFill>
-                  <a:srgbClr val="5B6577"/>
-                </a:solidFill>
-                <a:latin typeface="Carlito"/>
-              </a:rPr>
-              <a:t>terminadas</a:t>
-            </a:r>
-            <a:r>
-              <a:rPr sz="1100" dirty="0">
-                <a:solidFill>
-                  <a:srgbClr val="5B6577"/>
-                </a:solidFill>
-                <a:latin typeface="Carlito"/>
-              </a:rPr>
-              <a:t>.</a:t>
+              <a:t>El ajuste de alcance obligó a corregir y actualizar los documentos base (ERS, EDT, modelo de datos y plan de pruebas); esa corrección se presenta como evidencia de avance. Las etapas de construcción, integración y pruebas finales siguen planificadas: no se presentan como terminadas.</a:t>
             </a:r>
             <a:endParaRPr lang="en-US" sz="1300" dirty="0"/>
           </a:p>
@@ -14397,7 +13968,7 @@
         <p:spPr>
           <a:xfrm>
             <a:off x="2971605" y="1124671"/>
-            <a:ext cx="3291840" cy="274320"/>
+            <a:ext cx="3181961" cy="176972"/>
           </a:xfrm>
           <a:prstGeom prst="rect">
             <a:avLst/>
@@ -14452,13 +14023,13 @@
               <a:t> </a:t>
             </a:r>
             <a:r>
-              <a:rPr sz="1150" b="0" dirty="0" err="1">
+              <a:rPr lang="es-CL" sz="1150" b="0" dirty="0">
                 <a:solidFill>
                   <a:srgbClr val="1B1F2A"/>
                 </a:solidFill>
                 <a:latin typeface="Carlito"/>
               </a:rPr>
-              <a:t>por</a:t>
+              <a:t>por </a:t>
             </a:r>
             <a:r>
               <a:rPr sz="1150" b="0" dirty="0">
@@ -14467,16 +14038,16 @@
                 </a:solidFill>
                 <a:latin typeface="Carlito"/>
               </a:rPr>
-              <a:t> el </a:t>
-            </a:r>
-            <a:r>
-              <a:rPr sz="1150" b="0" dirty="0" err="1">
+              <a:t>p</a:t>
+            </a:r>
+            <a:r>
+              <a:rPr lang="es-CL" sz="1150" b="0" dirty="0" err="1">
                 <a:solidFill>
                   <a:srgbClr val="1B1F2A"/>
                 </a:solidFill>
                 <a:latin typeface="Carlito"/>
               </a:rPr>
-              <a:t>recorte</a:t>
+              <a:t>ropuestas</a:t>
             </a:r>
             <a:r>
               <a:rPr sz="1150" b="0" dirty="0">
@@ -14485,7 +14056,25 @@
                 </a:solidFill>
                 <a:latin typeface="Carlito"/>
               </a:rPr>
-              <a:t> de </a:t>
+              <a:t> </a:t>
+            </a:r>
+            <a:r>
+              <a:rPr lang="es-CL" sz="1150" b="0" dirty="0">
+                <a:solidFill>
+                  <a:srgbClr val="1B1F2A"/>
+                </a:solidFill>
+                <a:latin typeface="Carlito"/>
+              </a:rPr>
+              <a:t>d</a:t>
+            </a:r>
+            <a:r>
+              <a:rPr sz="1150" b="0" dirty="0">
+                <a:solidFill>
+                  <a:srgbClr val="1B1F2A"/>
+                </a:solidFill>
+                <a:latin typeface="Carlito"/>
+              </a:rPr>
+              <a:t>el </a:t>
             </a:r>
             <a:r>
               <a:rPr sz="1150" b="0" dirty="0" err="1">
@@ -15481,7 +15070,7 @@
                 </a:solidFill>
                 <a:latin typeface="Carlito"/>
               </a:rPr>
-              <a:t>Además: migración SQLite → PostgreSQL, pagos en custodia, integración con Transbank y transacciones con restricciones UNIQUE e idempotencia</a:t>
+              <a:t>Además: migración SQLite → PostgreSQL, integración con Transbank y transacciones con restricciones UNIQUE e idempotencia</a:t>
             </a:r>
           </a:p>
         </p:txBody>
@@ -16315,7 +15904,7 @@
                 <a:ea typeface="Carlito Bold" pitchFamily="34" charset="-122"/>
                 <a:cs typeface="Carlito Bold" pitchFamily="34" charset="-120"/>
               </a:rPr>
-              <a:t>21 requerimientos validados</a:t>
+              <a:t>22 requerimientos validados</a:t>
             </a:r>
             <a:endParaRPr lang="en-US" sz="1400" dirty="0"/>
           </a:p>
@@ -16565,7 +16154,7 @@
                 <a:ea typeface="Carlito Bold" pitchFamily="34" charset="-122"/>
                 <a:cs typeface="Carlito Bold" pitchFamily="34" charset="-120"/>
               </a:rPr>
-              <a:t>Solo Transbank Webpay Plus Test</a:t>
+              <a:t>Solo Transbank Webpay Mall (Split Payment)</a:t>
             </a:r>
             <a:endParaRPr lang="en-US" sz="1400" dirty="0"/>
           </a:p>
@@ -17065,7 +16654,7 @@
                 <a:ea typeface="Carlito Bold" pitchFamily="34" charset="-122"/>
                 <a:cs typeface="Carlito Bold" pitchFamily="34" charset="-120"/>
               </a:rPr>
-              <a:t>Calificación 1 a 5 y sanciones manuales</a:t>
+              <a:t>Moderación automática y sanciones manuales</a:t>
             </a:r>
             <a:endParaRPr lang="en-US" sz="1400" dirty="0"/>
           </a:p>
@@ -17784,7 +17373,7 @@
                 <a:ea typeface="Carlito" pitchFamily="34" charset="-122"/>
                 <a:cs typeface="Carlito" pitchFamily="34" charset="-120"/>
               </a:rPr>
-              <a:t>Webpay Plus Test, custodia, payout, código de entrega y calificaciones</a:t>
+              <a:t>Webpay Mall (Split Payment), código de entrega y calificaciones</a:t>
             </a:r>
             <a:endParaRPr lang="en-US" sz="1400" dirty="0"/>
           </a:p>
@@ -18864,7 +18453,7 @@
                 <a:ea typeface="Carlito" pitchFamily="34" charset="-122"/>
                 <a:cs typeface="Carlito" pitchFamily="34" charset="-120"/>
               </a:rPr>
-              <a:t>Pago con Webpay Plus, retenido hasta la entrega</a:t>
+              <a:t>Pago con Webpay Mall (Split Payment) al productor</a:t>
             </a:r>
             <a:endParaRPr lang="en-US" sz="1800" dirty="0"/>
           </a:p>
@@ -19126,18 +18715,7 @@
                 <a:ea typeface="Carlito Bold" pitchFamily="34" charset="-122"/>
                 <a:cs typeface="Carlito Bold" pitchFamily="34" charset="-120"/>
               </a:rPr>
-              <a:t>Administrador: </a:t>
-            </a:r>
-            <a:r>
-              <a:rPr lang="en-US" sz="1800" dirty="0">
-                <a:solidFill>
-                  <a:srgbClr val="1B1F2A"/>
-                </a:solidFill>
-                <a:latin typeface="Carlito" pitchFamily="34" charset="0"/>
-                <a:ea typeface="Carlito" pitchFamily="34" charset="-122"/>
-                <a:cs typeface="Carlito" pitchFamily="34" charset="-120"/>
-              </a:rPr>
-              <a:t>aprueba, modera y gestiona pagos</a:t>
+              <a:t>Administrador: aprueba, sanciona y atiende reclamos</a:t>
             </a:r>
             <a:endParaRPr lang="en-US" sz="1800" dirty="0"/>
           </a:p>
@@ -19804,7 +19382,7 @@
                 <a:ea typeface="Carlito" pitchFamily="34" charset="-122"/>
                 <a:cs typeface="Carlito" pitchFamily="34" charset="-120"/>
               </a:rPr>
-              <a:t>Frontend Vue.js y API FastAPI para Cliente, Vendedor y Administrador</a:t>
+              <a:t>Frontend Vue.js y Supabase para Cliente, Vendedor y Administrador</a:t>
             </a:r>
             <a:endParaRPr lang="en-US" sz="1600" dirty="0"/>
           </a:p>
@@ -19982,7 +19560,7 @@
                 <a:ea typeface="Carlito" pitchFamily="34" charset="-122"/>
                 <a:cs typeface="Carlito" pitchFamily="34" charset="-120"/>
               </a:rPr>
-              <a:t>Webpay Plus Test, pago retenido y entrega con código de verificación</a:t>
+              <a:t>Webpay Mall (Split Payment) y entrega con código de verificación</a:t>
             </a:r>
             <a:endParaRPr lang="en-US" sz="1600" dirty="0"/>
           </a:p>
@@ -20769,7 +20347,7 @@
             </a:pathLst>
           </a:custGeom>
           <a:solidFill>
-            <a:srgbClr val="5B6577"/>
+            <a:srgbClr val="C00000"/>
           </a:solidFill>
           <a:ln/>
         </p:spPr>
@@ -21214,7 +20792,7 @@
                 </a:solidFill>
                 <a:latin typeface="Carlito Bold"/>
               </a:rPr>
-              <a:t>Hoy: cerrando la fase 2</a:t>
+              <a:t>Hoy: fase 2 cerrada</a:t>
             </a:r>
             <a:endParaRPr lang="en-US" sz="1200" dirty="0"/>
           </a:p>
@@ -22029,7 +21607,7 @@
             <a:avLst/>
           </a:prstGeom>
           <a:solidFill>
-            <a:srgbClr val="0B2A55"/>
+            <a:srgbClr val="C00000"/>
           </a:solidFill>
           <a:ln>
             <a:noFill/>
@@ -22067,8 +21645,47 @@
         </p:nvSpPr>
         <p:spPr>
           <a:xfrm>
-            <a:off x="6618622" y="1197864"/>
-            <a:ext cx="347472" cy="347472"/>
+            <a:off x="6618622" y="1271572"/>
+            <a:ext cx="347472" cy="200055"/>
+          </a:xfrm>
+          <a:prstGeom prst="rect">
+            <a:avLst/>
+          </a:prstGeom>
+          <a:noFill/>
+        </p:spPr>
+        <p:txBody>
+          <a:bodyPr wrap="square" lIns="0" tIns="0" rIns="0" bIns="0" anchor="ctr">
+            <a:spAutoFit/>
+          </a:bodyPr>
+          <a:lstStyle/>
+          <a:p>
+            <a:pPr algn="ctr">
+              <a:lnSpc>
+                <a:spcPct val="100000"/>
+              </a:lnSpc>
+            </a:pPr>
+            <a:r>
+              <a:rPr sz="1300" b="1" dirty="0">
+                <a:solidFill>
+                  <a:srgbClr val="FFFFFF"/>
+                </a:solidFill>
+                <a:latin typeface="Carlito Bold"/>
+              </a:rPr>
+              <a:t>3</a:t>
+            </a:r>
+          </a:p>
+        </p:txBody>
+      </p:sp>
+      <p:sp>
+        <p:nvSpPr>
+          <p:cNvPr id="48" name="TextBox 47"/>
+          <p:cNvSpPr txBox="1"/>
+          <p:nvPr/>
+        </p:nvSpPr>
+        <p:spPr>
+          <a:xfrm>
+            <a:off x="7818120" y="1197864"/>
+            <a:ext cx="1737360" cy="347472"/>
           </a:xfrm>
           <a:prstGeom prst="rect">
             <a:avLst/>
@@ -22081,33 +21698,33 @@
           </a:bodyPr>
           <a:lstStyle/>
           <a:p>
-            <a:pPr algn="ctr">
+            <a:pPr algn="l">
               <a:lnSpc>
                 <a:spcPct val="100000"/>
               </a:lnSpc>
             </a:pPr>
             <a:r>
-              <a:rPr sz="1300" b="1" dirty="0">
-                <a:solidFill>
-                  <a:srgbClr val="FFFFFF"/>
+              <a:rPr sz="1200" b="1">
+                <a:solidFill>
+                  <a:srgbClr val="0B2A55"/>
                 </a:solidFill>
                 <a:latin typeface="Carlito Bold"/>
               </a:rPr>
-              <a:t>3</a:t>
-            </a:r>
-          </a:p>
-        </p:txBody>
-      </p:sp>
-      <p:sp>
-        <p:nvSpPr>
-          <p:cNvPr id="48" name="TextBox 47"/>
+              <a:t>Construcción · en curso</a:t>
+            </a:r>
+          </a:p>
+        </p:txBody>
+      </p:sp>
+      <p:sp>
+        <p:nvSpPr>
+          <p:cNvPr id="49" name="TextBox 48"/>
           <p:cNvSpPr txBox="1"/>
           <p:nvPr/>
         </p:nvSpPr>
         <p:spPr>
           <a:xfrm>
-            <a:off x="7818120" y="1197864"/>
-            <a:ext cx="1737360" cy="347472"/>
+            <a:off x="9555480" y="1197864"/>
+            <a:ext cx="1920240" cy="347472"/>
           </a:xfrm>
           <a:prstGeom prst="rect">
             <a:avLst/>
@@ -22120,58 +21737,19 @@
           </a:bodyPr>
           <a:lstStyle/>
           <a:p>
-            <a:pPr algn="l">
+            <a:pPr algn="r">
               <a:lnSpc>
                 <a:spcPct val="100000"/>
               </a:lnSpc>
             </a:pPr>
             <a:r>
-              <a:rPr sz="1200" b="1">
-                <a:solidFill>
-                  <a:srgbClr val="0B2A55"/>
-                </a:solidFill>
-                <a:latin typeface="Carlito Bold"/>
-              </a:rPr>
-              <a:t>Construcción · en curso</a:t>
-            </a:r>
-          </a:p>
-        </p:txBody>
-      </p:sp>
-      <p:sp>
-        <p:nvSpPr>
-          <p:cNvPr id="49" name="TextBox 48"/>
-          <p:cNvSpPr txBox="1"/>
-          <p:nvPr/>
-        </p:nvSpPr>
-        <p:spPr>
-          <a:xfrm>
-            <a:off x="9555480" y="1197864"/>
-            <a:ext cx="1920240" cy="347472"/>
-          </a:xfrm>
-          <a:prstGeom prst="rect">
-            <a:avLst/>
-          </a:prstGeom>
-          <a:noFill/>
-        </p:spPr>
-        <p:txBody>
-          <a:bodyPr wrap="none" lIns="0" tIns="0" rIns="0" bIns="0" anchor="ctr">
-            <a:spAutoFit/>
-          </a:bodyPr>
-          <a:lstStyle/>
-          <a:p>
-            <a:pPr algn="r">
-              <a:lnSpc>
-                <a:spcPct val="100000"/>
-              </a:lnSpc>
-            </a:pPr>
-            <a:r>
               <a:rPr sz="1100" b="0">
                 <a:solidFill>
                   <a:srgbClr val="5B6577"/>
                 </a:solidFill>
                 <a:latin typeface="Carlito"/>
               </a:rPr>
-              <a:t>Hoy · 4 oct · semana 4 de 13</a:t>
+              <a:t>Hoy · 15 oct · semana 5 de 13</a:t>
             </a:r>
           </a:p>
         </p:txBody>
@@ -22650,7 +22228,7 @@
         </p:nvSpPr>
         <p:spPr>
           <a:xfrm>
-            <a:off x="7085133" y="3246041"/>
+            <a:off x="5812593" y="3246041"/>
             <a:ext cx="12700" cy="356691"/>
           </a:xfrm>
           <a:prstGeom prst="rect">
@@ -22677,7 +22255,7 @@
         </p:nvSpPr>
         <p:spPr>
           <a:xfrm>
-            <a:off x="6405700" y="2101532"/>
+            <a:off x="5133160" y="2101532"/>
             <a:ext cx="1371566" cy="274241"/>
           </a:xfrm>
           <a:prstGeom prst="rect">
@@ -22719,7 +22297,7 @@
         </p:nvSpPr>
         <p:spPr>
           <a:xfrm>
-            <a:off x="6405700" y="2365006"/>
+            <a:off x="5133160" y="2365006"/>
             <a:ext cx="1371566" cy="426641"/>
           </a:xfrm>
           <a:prstGeom prst="rect">
@@ -22763,7 +22341,7 @@
         </p:nvSpPr>
         <p:spPr>
           <a:xfrm>
-            <a:off x="6100908" y="2797651"/>
+            <a:off x="4828368" y="2797651"/>
             <a:ext cx="1981150" cy="198041"/>
           </a:xfrm>
           <a:prstGeom prst="rect">
@@ -22791,7 +22369,7 @@
                 <a:ea typeface="Carlito" pitchFamily="34" charset="-122"/>
                 <a:cs typeface="Carlito" pitchFamily="34" charset="-120"/>
               </a:rPr>
-              <a:t>05/11 · S8</a:t>
+              <a:t>08/10 · S4</a:t>
             </a:r>
             <a:endParaRPr lang="en-US" sz="1300" dirty="0"/>
           </a:p>
@@ -22805,7 +22383,7 @@
         </p:nvSpPr>
         <p:spPr>
           <a:xfrm>
-            <a:off x="6945139" y="3602732"/>
+            <a:off x="5672599" y="3602732"/>
             <a:ext cx="292589" cy="292596"/>
           </a:xfrm>
           <a:prstGeom prst="ellipse">
@@ -23583,7 +23161,7 @@
         </p:nvSpPr>
         <p:spPr>
           <a:xfrm>
-            <a:off x="3697592" y="3154660"/>
+            <a:off x="6897992" y="3154660"/>
             <a:ext cx="25399" cy="594320"/>
           </a:xfrm>
           <a:prstGeom prst="rect">
@@ -23610,7 +23188,7 @@
         </p:nvSpPr>
         <p:spPr>
           <a:xfrm>
-            <a:off x="3070247" y="2816324"/>
+            <a:off x="6270647" y="2816324"/>
             <a:ext cx="1280088" cy="338237"/>
           </a:xfrm>
           <a:prstGeom prst="roundRect">
@@ -23644,7 +23222,7 @@
         </p:nvSpPr>
         <p:spPr>
           <a:xfrm>
-            <a:off x="2765455" y="2872482"/>
+            <a:off x="5965855" y="2872482"/>
             <a:ext cx="1889673" cy="247650"/>
           </a:xfrm>
           <a:prstGeom prst="rect">
@@ -23672,7 +23250,7 @@
                 <a:ea typeface="Carlito Bold" pitchFamily="34" charset="-122"/>
                 <a:cs typeface="Carlito Bold" pitchFamily="34" charset="-120"/>
               </a:rPr>
-              <a:t>Hoy · 4 oct</a:t>
+              <a:t>Hoy · 15 oct</a:t>
             </a:r>
             <a:endParaRPr lang="en-US" sz="1300" dirty="0"/>
           </a:p>
@@ -24087,7 +23665,7 @@
                 <a:ea typeface="Carlito Bold" pitchFamily="34" charset="-122"/>
                 <a:cs typeface="Carlito Bold" pitchFamily="34" charset="-120"/>
               </a:rPr>
-              <a:t>Resumen de avance al 4 de octubre</a:t>
+              <a:t>Resumen de avance al 15 de octubre</a:t>
             </a:r>
             <a:endParaRPr lang="en-US" sz="3400" dirty="0"/>
           </a:p>
@@ -24129,7 +23707,7 @@
                 <a:ea typeface="Carlito Bold" pitchFamily="34" charset="-122"/>
                 <a:cs typeface="Carlito Bold" pitchFamily="34" charset="-120"/>
               </a:rPr>
-              <a:t>Estado de las 13 actividades del plan</a:t>
+              <a:t>Estado de las 13 actividades del plan al corte del 05/10</a:t>
             </a:r>
             <a:endParaRPr lang="en-US" sz="1400" dirty="0"/>
           </a:p>
@@ -24205,7 +23783,7 @@
                 <a:ea typeface="Carlito Bold" pitchFamily="34" charset="-122"/>
                 <a:cs typeface="Carlito Bold" pitchFamily="34" charset="-120"/>
               </a:rPr>
-              <a:t>5 de 13</a:t>
+              <a:t>7 de 13</a:t>
             </a:r>
             <a:endParaRPr lang="en-US" sz="3800" dirty="0"/>
           </a:p>
@@ -24369,7 +23947,7 @@
                 <a:ea typeface="Carlito" pitchFamily="34" charset="-122"/>
                 <a:cs typeface="Carlito" pitchFamily="34" charset="-120"/>
               </a:rPr>
-              <a:t>registradas de 520 h planificadas para el equipo de dos personas</a:t>
+              <a:t>registradas al corte del 05/10 de 520 h planificadas para el equipo</a:t>
             </a:r>
             <a:endParaRPr lang="en-US" sz="1400" dirty="0"/>
           </a:p>
@@ -24592,7 +24170,7 @@
           <p:nvPr>
             <p:extLst>
               <p:ext uri="{D42A27DB-BD31-4B8C-83A1-F6EECF244321}">
-                <p14:modId xmlns:p14="http://schemas.microsoft.com/office/powerpoint/2010/main" val="2770874855"/>
+                <p14:modId xmlns:p14="http://schemas.microsoft.com/office/powerpoint/2010/main" val="1629944090"/>
               </p:ext>
             </p:extLst>
           </p:nvPr>
@@ -24704,7 +24282,7 @@
           <a:bodyPr/>
           <a:lstStyle/>
           <a:p>
-            <a:endParaRPr lang="es-CL"/>
+            <a:endParaRPr lang="es-CL" dirty="0"/>
           </a:p>
         </p:txBody>
       </p:sp>
@@ -24744,7 +24322,7 @@
                 <a:ea typeface="Carlito Bold" pitchFamily="34" charset="-122"/>
                 <a:cs typeface="Carlito Bold" pitchFamily="34" charset="-120"/>
               </a:rPr>
-              <a:t>Completado · 5</a:t>
+              <a:t>Completado · 7</a:t>
             </a:r>
             <a:endParaRPr lang="en-US" sz="1600" dirty="0"/>
           </a:p>
@@ -24767,7 +24345,10 @@
             </a:avLst>
           </a:prstGeom>
           <a:solidFill>
-            <a:srgbClr val="EEF2F7"/>
+            <a:schemeClr val="accent6">
+              <a:lumMod val="20000"/>
+              <a:lumOff val="80000"/>
+            </a:schemeClr>
           </a:solidFill>
           <a:ln w="12700">
             <a:solidFill>
@@ -24885,7 +24466,10 @@
             </a:avLst>
           </a:prstGeom>
           <a:solidFill>
-            <a:srgbClr val="EEF2F7"/>
+            <a:schemeClr val="accent6">
+              <a:lumMod val="20000"/>
+              <a:lumOff val="80000"/>
+            </a:schemeClr>
           </a:solidFill>
           <a:ln w="12700">
             <a:solidFill>
@@ -25003,7 +24587,10 @@
             </a:avLst>
           </a:prstGeom>
           <a:solidFill>
-            <a:srgbClr val="EEF2F7"/>
+            <a:schemeClr val="accent6">
+              <a:lumMod val="20000"/>
+              <a:lumOff val="80000"/>
+            </a:schemeClr>
           </a:solidFill>
           <a:ln w="12700">
             <a:solidFill>
@@ -25121,7 +24708,10 @@
             </a:avLst>
           </a:prstGeom>
           <a:solidFill>
-            <a:srgbClr val="EEF2F7"/>
+            <a:schemeClr val="accent6">
+              <a:lumMod val="20000"/>
+              <a:lumOff val="80000"/>
+            </a:schemeClr>
           </a:solidFill>
           <a:ln w="12700">
             <a:solidFill>
@@ -25239,7 +24829,10 @@
             </a:avLst>
           </a:prstGeom>
           <a:solidFill>
-            <a:srgbClr val="EEF2F7"/>
+            <a:schemeClr val="accent6">
+              <a:lumMod val="20000"/>
+              <a:lumOff val="80000"/>
+            </a:schemeClr>
           </a:solidFill>
           <a:ln w="12700">
             <a:solidFill>
@@ -25348,7 +24941,7 @@
         </p:nvSpPr>
         <p:spPr>
           <a:xfrm>
-            <a:off x="4337140" y="1417241"/>
+            <a:off x="4337140" y="3024089"/>
             <a:ext cx="3514240" cy="457200"/>
           </a:xfrm>
           <a:prstGeom prst="roundRect">
@@ -25370,7 +24963,7 @@
           <a:bodyPr/>
           <a:lstStyle/>
           <a:p>
-            <a:endParaRPr lang="es-CL"/>
+            <a:endParaRPr lang="es-CL" dirty="0"/>
           </a:p>
         </p:txBody>
       </p:sp>
@@ -25382,7 +24975,7 @@
         </p:nvSpPr>
         <p:spPr>
           <a:xfrm>
-            <a:off x="4565734" y="1510010"/>
+            <a:off x="4565734" y="3116858"/>
             <a:ext cx="3666636" cy="304800"/>
           </a:xfrm>
           <a:prstGeom prst="rect">
@@ -25410,7 +25003,7 @@
                 <a:ea typeface="Carlito Bold" pitchFamily="34" charset="-122"/>
                 <a:cs typeface="Carlito Bold" pitchFamily="34" charset="-120"/>
               </a:rPr>
-              <a:t>En curso · 4</a:t>
+              <a:t>En curso · 3</a:t>
             </a:r>
             <a:endParaRPr lang="en-US" sz="1600" dirty="0"/>
           </a:p>
@@ -25424,7 +25017,7 @@
         </p:nvSpPr>
         <p:spPr>
           <a:xfrm>
-            <a:off x="4337140" y="2011660"/>
+            <a:off x="4337140" y="1389856"/>
             <a:ext cx="3514240" cy="694928"/>
           </a:xfrm>
           <a:prstGeom prst="roundRect">
@@ -25433,7 +25026,10 @@
             </a:avLst>
           </a:prstGeom>
           <a:solidFill>
-            <a:srgbClr val="EEF2F7"/>
+            <a:schemeClr val="accent6">
+              <a:lumMod val="20000"/>
+              <a:lumOff val="80000"/>
+            </a:schemeClr>
           </a:solidFill>
           <a:ln w="12700">
             <a:solidFill>
@@ -25458,7 +25054,7 @@
         </p:nvSpPr>
         <p:spPr>
           <a:xfrm>
-            <a:off x="4565734" y="2131814"/>
+            <a:off x="4565734" y="1510010"/>
             <a:ext cx="3666636" cy="266700"/>
           </a:xfrm>
           <a:prstGeom prst="rect">
@@ -25500,7 +25096,7 @@
         </p:nvSpPr>
         <p:spPr>
           <a:xfrm>
-            <a:off x="4565734" y="2398514"/>
+            <a:off x="4565734" y="1776710"/>
             <a:ext cx="3666636" cy="228600"/>
           </a:xfrm>
           <a:prstGeom prst="rect">
@@ -25542,7 +25138,7 @@
         </p:nvSpPr>
         <p:spPr>
           <a:xfrm>
-            <a:off x="4337140" y="2816324"/>
+            <a:off x="4337140" y="2194520"/>
             <a:ext cx="3514240" cy="694928"/>
           </a:xfrm>
           <a:prstGeom prst="roundRect">
@@ -25551,7 +25147,10 @@
             </a:avLst>
           </a:prstGeom>
           <a:solidFill>
-            <a:srgbClr val="EEF2F7"/>
+            <a:schemeClr val="accent6">
+              <a:lumMod val="20000"/>
+              <a:lumOff val="80000"/>
+            </a:schemeClr>
           </a:solidFill>
           <a:ln w="12700">
             <a:solidFill>
@@ -25576,7 +25175,7 @@
         </p:nvSpPr>
         <p:spPr>
           <a:xfrm>
-            <a:off x="4565734" y="2936478"/>
+            <a:off x="4565734" y="2314674"/>
             <a:ext cx="3666636" cy="266700"/>
           </a:xfrm>
           <a:prstGeom prst="rect">
@@ -25618,7 +25217,7 @@
         </p:nvSpPr>
         <p:spPr>
           <a:xfrm>
-            <a:off x="4565734" y="3203178"/>
+            <a:off x="4565734" y="2581374"/>
             <a:ext cx="3666636" cy="228600"/>
           </a:xfrm>
           <a:prstGeom prst="rect">
@@ -25669,7 +25268,10 @@
             </a:avLst>
           </a:prstGeom>
           <a:solidFill>
-            <a:srgbClr val="EEF2F7"/>
+            <a:schemeClr val="accent4">
+              <a:lumMod val="40000"/>
+              <a:lumOff val="60000"/>
+            </a:schemeClr>
           </a:solidFill>
           <a:ln w="12700">
             <a:solidFill>
@@ -25722,7 +25324,7 @@
                 <a:ea typeface="Carlito Bold" pitchFamily="34" charset="-122"/>
                 <a:cs typeface="Carlito Bold" pitchFamily="34" charset="-120"/>
               </a:rPr>
-              <a:t>Backend, API y autenticación</a:t>
+              <a:t>Backend, PostgREST y autenticación</a:t>
             </a:r>
             <a:endParaRPr lang="en-US" sz="1400" dirty="0"/>
           </a:p>
@@ -25787,7 +25389,10 @@
             </a:avLst>
           </a:prstGeom>
           <a:solidFill>
-            <a:srgbClr val="EEF2F7"/>
+            <a:schemeClr val="accent4">
+              <a:lumMod val="40000"/>
+              <a:lumOff val="60000"/>
+            </a:schemeClr>
           </a:solidFill>
           <a:ln w="12700">
             <a:solidFill>
@@ -25896,7 +25501,7 @@
         </p:nvSpPr>
         <p:spPr>
           <a:xfrm>
-            <a:off x="8125713" y="1417241"/>
+            <a:off x="8125713" y="2213124"/>
             <a:ext cx="3514240" cy="457200"/>
           </a:xfrm>
           <a:prstGeom prst="roundRect">
@@ -25930,7 +25535,7 @@
         </p:nvSpPr>
         <p:spPr>
           <a:xfrm>
-            <a:off x="8354307" y="1510010"/>
+            <a:off x="8354307" y="2305893"/>
             <a:ext cx="3666636" cy="304800"/>
           </a:xfrm>
           <a:prstGeom prst="rect">
@@ -25958,7 +25563,7 @@
                 <a:ea typeface="Carlito Bold" pitchFamily="34" charset="-122"/>
                 <a:cs typeface="Carlito Bold" pitchFamily="34" charset="-120"/>
               </a:rPr>
-              <a:t>No iniciado · 4</a:t>
+              <a:t>No iniciado · 3</a:t>
             </a:r>
             <a:endParaRPr lang="en-US" sz="1600" dirty="0"/>
           </a:p>
@@ -25972,7 +25577,7 @@
         </p:nvSpPr>
         <p:spPr>
           <a:xfrm>
-            <a:off x="8125713" y="2011660"/>
+            <a:off x="8125714" y="1391146"/>
             <a:ext cx="3514240" cy="694928"/>
           </a:xfrm>
           <a:prstGeom prst="roundRect">
@@ -25981,7 +25586,10 @@
             </a:avLst>
           </a:prstGeom>
           <a:solidFill>
-            <a:srgbClr val="EEF2F7"/>
+            <a:schemeClr val="accent4">
+              <a:lumMod val="40000"/>
+              <a:lumOff val="60000"/>
+            </a:schemeClr>
           </a:solidFill>
           <a:ln w="12700">
             <a:solidFill>
@@ -26006,7 +25614,7 @@
         </p:nvSpPr>
         <p:spPr>
           <a:xfrm>
-            <a:off x="8354307" y="2131814"/>
+            <a:off x="8354308" y="1511300"/>
             <a:ext cx="3666636" cy="266700"/>
           </a:xfrm>
           <a:prstGeom prst="rect">
@@ -26048,7 +25656,7 @@
         </p:nvSpPr>
         <p:spPr>
           <a:xfrm>
-            <a:off x="8354307" y="2398514"/>
+            <a:off x="8354308" y="1778000"/>
             <a:ext cx="3666636" cy="228600"/>
           </a:xfrm>
           <a:prstGeom prst="rect">
@@ -26099,7 +25707,10 @@
             </a:avLst>
           </a:prstGeom>
           <a:solidFill>
-            <a:srgbClr val="EEF2F7"/>
+            <a:schemeClr val="tx2">
+              <a:lumMod val="20000"/>
+              <a:lumOff val="80000"/>
+            </a:schemeClr>
           </a:solidFill>
           <a:ln w="12700">
             <a:solidFill>
@@ -26152,7 +25763,7 @@
                 <a:ea typeface="Carlito Bold" pitchFamily="34" charset="-122"/>
                 <a:cs typeface="Carlito Bold" pitchFamily="34" charset="-120"/>
               </a:rPr>
-              <a:t>Pagos y reglas de negocio</a:t>
+              <a:t>Webpay Mall y reglas de negocio</a:t>
             </a:r>
             <a:endParaRPr lang="en-US" sz="1400" dirty="0"/>
           </a:p>
@@ -26217,7 +25828,10 @@
             </a:avLst>
           </a:prstGeom>
           <a:solidFill>
-            <a:srgbClr val="EEF2F7"/>
+            <a:schemeClr val="tx2">
+              <a:lumMod val="20000"/>
+              <a:lumOff val="80000"/>
+            </a:schemeClr>
           </a:solidFill>
           <a:ln w="12700">
             <a:solidFill>
@@ -26335,7 +25949,10 @@
             </a:avLst>
           </a:prstGeom>
           <a:solidFill>
-            <a:srgbClr val="EEF2F7"/>
+            <a:schemeClr val="tx2">
+              <a:lumMod val="20000"/>
+              <a:lumOff val="80000"/>
+            </a:schemeClr>
           </a:solidFill>
           <a:ln w="12700">
             <a:solidFill>
@@ -27312,23 +26929,8 @@
                 </a:solidFill>
                 <a:latin typeface="Carlito"/>
               </a:rPr>
-              <a:t>• </a:t>
-            </a:r>
-            <a:r>
-              <a:rPr sz="1150" dirty="0">
-                <a:solidFill>
-                  <a:srgbClr val="FFFFFF"/>
-                </a:solidFill>
-                <a:latin typeface="Carlito"/>
-              </a:rPr>
-              <a:t>CRUD</a:t>
-            </a:r>
-            <a:endParaRPr lang="es-CL" sz="1150" dirty="0">
-              <a:solidFill>
-                <a:srgbClr val="FFFFFF"/>
-              </a:solidFill>
-              <a:latin typeface="Carlito"/>
-            </a:endParaRPr>
+              <a:t>• Creación y confirmación del pago</a:t>
+            </a:r>
           </a:p>
           <a:p>
             <a:pPr algn="l">
@@ -27416,59 +27018,8 @@
                 </a:solidFill>
                 <a:latin typeface="Carlito"/>
               </a:rPr>
-              <a:t>• </a:t>
-            </a:r>
-            <a:r>
-              <a:rPr sz="1150" dirty="0" err="1">
-                <a:solidFill>
-                  <a:srgbClr val="FFFFFF"/>
-                </a:solidFill>
-                <a:latin typeface="Carlito"/>
-              </a:rPr>
-              <a:t>Correos</a:t>
-            </a:r>
-            <a:r>
-              <a:rPr sz="1150" dirty="0">
-                <a:solidFill>
-                  <a:srgbClr val="FFFFFF"/>
-                </a:solidFill>
-                <a:latin typeface="Carlito"/>
-              </a:rPr>
-              <a:t> con </a:t>
-            </a:r>
-            <a:r>
-              <a:rPr sz="1150" dirty="0" err="1">
-                <a:solidFill>
-                  <a:srgbClr val="FFFFFF"/>
-                </a:solidFill>
-                <a:latin typeface="Carlito"/>
-              </a:rPr>
-              <a:t>plantillas</a:t>
-            </a:r>
-            <a:r>
-              <a:rPr sz="1150" dirty="0">
-                <a:solidFill>
-                  <a:srgbClr val="FFFFFF"/>
-                </a:solidFill>
-                <a:latin typeface="Carlito"/>
-              </a:rPr>
-              <a:t> </a:t>
-            </a:r>
-            <a:r>
-              <a:rPr sz="1150" dirty="0" err="1">
-                <a:solidFill>
-                  <a:srgbClr val="FFFFFF"/>
-                </a:solidFill>
-                <a:latin typeface="Carlito"/>
-              </a:rPr>
-              <a:t>personalizadas</a:t>
-            </a:r>
-            <a:endParaRPr sz="1150" dirty="0">
-              <a:solidFill>
-                <a:srgbClr val="FFFFFF"/>
-              </a:solidFill>
-              <a:latin typeface="Carlito"/>
-            </a:endParaRPr>
+              <a:t>• Idempotencia por buy_order y token_ws</a:t>
+            </a:r>
           </a:p>
           <a:p>
             <a:pPr algn="l">
@@ -27486,77 +27037,8 @@
                 </a:solidFill>
                 <a:latin typeface="Carlito"/>
               </a:rPr>
-              <a:t>• </a:t>
-            </a:r>
-            <a:r>
-              <a:rPr sz="1150" dirty="0" err="1">
-                <a:solidFill>
-                  <a:srgbClr val="FFFFFF"/>
-                </a:solidFill>
-                <a:latin typeface="Carlito"/>
-              </a:rPr>
-              <a:t>Cifrado</a:t>
-            </a:r>
-            <a:r>
-              <a:rPr sz="1150" dirty="0">
-                <a:solidFill>
-                  <a:srgbClr val="FFFFFF"/>
-                </a:solidFill>
-                <a:latin typeface="Carlito"/>
-              </a:rPr>
-              <a:t> </a:t>
-            </a:r>
-            <a:r>
-              <a:rPr sz="1150" dirty="0" err="1">
-                <a:solidFill>
-                  <a:srgbClr val="FFFFFF"/>
-                </a:solidFill>
-                <a:latin typeface="Carlito"/>
-              </a:rPr>
-              <a:t>parcial</a:t>
-            </a:r>
-            <a:r>
-              <a:rPr sz="1150" dirty="0">
-                <a:solidFill>
-                  <a:srgbClr val="FFFFFF"/>
-                </a:solidFill>
-                <a:latin typeface="Carlito"/>
-              </a:rPr>
-              <a:t> de </a:t>
-            </a:r>
-            <a:r>
-              <a:rPr sz="1150" dirty="0" err="1">
-                <a:solidFill>
-                  <a:srgbClr val="FFFFFF"/>
-                </a:solidFill>
-                <a:latin typeface="Carlito"/>
-              </a:rPr>
-              <a:t>datos</a:t>
-            </a:r>
-            <a:r>
-              <a:rPr sz="1150" dirty="0">
-                <a:solidFill>
-                  <a:srgbClr val="FFFFFF"/>
-                </a:solidFill>
-                <a:latin typeface="Carlito"/>
-              </a:rPr>
-              <a:t> </a:t>
-            </a:r>
-            <a:r>
-              <a:rPr sz="1150" dirty="0" err="1">
-                <a:solidFill>
-                  <a:srgbClr val="FFFFFF"/>
-                </a:solidFill>
-                <a:latin typeface="Carlito"/>
-              </a:rPr>
-              <a:t>sensibles</a:t>
-            </a:r>
-            <a:endParaRPr sz="1150" dirty="0">
-              <a:solidFill>
-                <a:srgbClr val="FFFFFF"/>
-              </a:solidFill>
-              <a:latin typeface="Carlito"/>
-            </a:endParaRPr>
+              <a:t>• Cálculo del neto del Split Payment</a:t>
+            </a:r>
           </a:p>
         </p:txBody>
       </p:sp>
@@ -27641,52 +27123,7 @@
                 </a:solidFill>
                 <a:latin typeface="Carlito Bold"/>
               </a:rPr>
-              <a:t>Cloud Run: </a:t>
-            </a:r>
-            <a:r>
-              <a:rPr sz="1550" b="1" dirty="0" err="1">
-                <a:solidFill>
-                  <a:srgbClr val="FFFFFF"/>
-                </a:solidFill>
-                <a:latin typeface="Carlito Bold"/>
-              </a:rPr>
-              <a:t>reglas</a:t>
-            </a:r>
-            <a:r>
-              <a:rPr sz="1550" b="1" dirty="0">
-                <a:solidFill>
-                  <a:srgbClr val="FFFFFF"/>
-                </a:solidFill>
-                <a:latin typeface="Carlito Bold"/>
-              </a:rPr>
-              <a:t> de </a:t>
-            </a:r>
-            <a:r>
-              <a:rPr sz="1550" b="1" dirty="0" err="1">
-                <a:solidFill>
-                  <a:srgbClr val="FFFFFF"/>
-                </a:solidFill>
-                <a:latin typeface="Carlito Bold"/>
-              </a:rPr>
-              <a:t>negocio</a:t>
-            </a:r>
-            <a:r>
-              <a:rPr sz="1550" b="1" dirty="0">
-                <a:solidFill>
-                  <a:srgbClr val="FFFFFF"/>
-                </a:solidFill>
-                <a:latin typeface="Carlito Bold"/>
-              </a:rPr>
-              <a:t> </a:t>
-            </a:r>
-            <a:r>
-              <a:rPr sz="1550" b="1" dirty="0" err="1">
-                <a:solidFill>
-                  <a:srgbClr val="FFFFFF"/>
-                </a:solidFill>
-                <a:latin typeface="Carlito Bold"/>
-              </a:rPr>
-              <a:t>complejas</a:t>
+              <a:t>Cloud Run: solo la integración con Webpay</a:t>
             </a:r>
             <a:endParaRPr lang="en-US" sz="1400" dirty="0"/>
           </a:p>
@@ -27882,7 +27319,7 @@
                 <a:ea typeface="Carlito Bold" pitchFamily="34" charset="-122"/>
                 <a:cs typeface="Carlito Bold" pitchFamily="34" charset="-120"/>
               </a:rPr>
-              <a:t>Webpay Plus Test</a:t>
+              <a:t>Webpay Mall</a:t>
             </a:r>
             <a:endParaRPr lang="en-US" sz="1800" dirty="0"/>
           </a:p>
@@ -27926,7 +27363,7 @@
                 <a:ea typeface="Carlito" pitchFamily="34" charset="-122"/>
                 <a:cs typeface="Carlito" pitchFamily="34" charset="-120"/>
               </a:rPr>
-              <a:t>Transbank, ambiente de pruebas</a:t>
+              <a:t>Transbank, Split Payment en pruebas</a:t>
             </a:r>
             <a:endParaRPr lang="en-US" sz="1400" dirty="0"/>
           </a:p>
@@ -29564,7 +29001,7 @@
                 <a:ea typeface="Carlito Bold" pitchFamily="34" charset="-122"/>
                 <a:cs typeface="Carlito Bold" pitchFamily="34" charset="-120"/>
               </a:rPr>
-              <a:t>payouts</a:t>
+              <a:t>claims</a:t>
             </a:r>
             <a:endParaRPr lang="en-US" sz="1300" dirty="0"/>
           </a:p>

</xml_diff>